<commit_message>
Add 5 live KEFI chatbot outcome photos to Slide 5 in presentation PDF and PPTX
</commit_message>
<xml_diff>
--- a/SIH2026_DEKO_SIH26094_Presentation.pptx
+++ b/SIH2026_DEKO_SIH26094_Presentation.pptx
@@ -8245,7 +8245,7 @@
         <p:spPr>
           <a:xfrm>
             <a:off x="685800" y="4343400"/>
-            <a:ext cx="2066543" cy="1828800"/>
+            <a:ext cx="2066543" cy="1874519"/>
           </a:xfrm>
           <a:prstGeom prst="roundRect">
             <a:avLst/>
@@ -8332,8 +8332,8 @@
         </p:nvSpPr>
         <p:spPr>
           <a:xfrm>
-            <a:off x="758952" y="4434840"/>
-            <a:ext cx="1920239" cy="1645920"/>
+            <a:off x="740664" y="4407408"/>
+            <a:ext cx="1956815" cy="256032"/>
           </a:xfrm>
           <a:prstGeom prst="rect">
             <a:avLst/>
@@ -8341,58 +8341,58 @@
           <a:noFill/>
         </p:spPr>
         <p:txBody>
-          <a:bodyPr wrap="square">
+          <a:bodyPr wrap="none">
             <a:spAutoFit/>
           </a:bodyPr>
           <a:lstStyle/>
           <a:p>
             <a:pPr>
-              <a:defRPr b="1" sz="900">
+              <a:defRPr b="1" sz="850">
                 <a:solidFill>
                   <a:srgbClr val="123A8A"/>
                 </a:solidFill>
               </a:defRPr>
             </a:pPr>
             <a:r>
-              <a:t>[1] OMNICHANNEL AUDIO</a:t>
-            </a:r>
-          </a:p>
-          <a:p>
-            <a:pPr>
-              <a:defRPr b="1" sz="850">
-                <a:solidFill>
-                  <a:srgbClr val="0F172A"/>
-                </a:solidFill>
-              </a:defRPr>
-            </a:pPr>
-            <a:r>
-              <a:t>Tanglish Voice &amp; Chatbot</a:t>
-            </a:r>
-          </a:p>
-          <a:p>
-            <a:pPr>
-              <a:defRPr sz="800">
-                <a:solidFill>
-                  <a:srgbClr val="64748B"/>
-                </a:solidFill>
-              </a:defRPr>
-            </a:pPr>
-            <a:r>
-              <a:t>IVRS 14566, WebRTC mic &amp; mobile text chat with code-mixing.</a:t>
-            </a:r>
-          </a:p>
-        </p:txBody>
-      </p:sp>
-      <p:sp>
-        <p:nvSpPr>
-          <p:cNvPr id="14" name="Rounded Rectangle 13"/>
+              <a:t>Outcome 1: Tanglish Chatbot</a:t>
+            </a:r>
+          </a:p>
+        </p:txBody>
+      </p:sp>
+      <p:pic>
+        <p:nvPicPr>
+          <p:cNvPr id="14" name="Picture 13" descr="photo_outcome1_chat.png"/>
+          <p:cNvPicPr>
+            <a:picLocks noChangeAspect="1"/>
+          </p:cNvPicPr>
+          <p:nvPr/>
+        </p:nvPicPr>
+        <p:blipFill>
+          <a:blip r:embed="rId3"/>
+          <a:stretch>
+            <a:fillRect/>
+          </a:stretch>
+        </p:blipFill>
+        <p:spPr>
+          <a:xfrm>
+            <a:off x="740664" y="4681728"/>
+            <a:ext cx="1956815" cy="1444752"/>
+          </a:xfrm>
+          <a:prstGeom prst="rect">
+            <a:avLst/>
+          </a:prstGeom>
+        </p:spPr>
+      </p:pic>
+      <p:sp>
+        <p:nvSpPr>
+          <p:cNvPr id="15" name="Rounded Rectangle 14"/>
           <p:cNvSpPr/>
           <p:nvPr/>
         </p:nvSpPr>
         <p:spPr>
           <a:xfrm>
             <a:off x="2862071" y="4343400"/>
-            <a:ext cx="2066543" cy="1828800"/>
+            <a:ext cx="2066543" cy="1874519"/>
           </a:xfrm>
           <a:prstGeom prst="roundRect">
             <a:avLst/>
@@ -8430,7 +8430,7 @@
       </p:sp>
       <p:sp>
         <p:nvSpPr>
-          <p:cNvPr id="15" name="Rectangle 14"/>
+          <p:cNvPr id="16" name="Rectangle 15"/>
           <p:cNvSpPr/>
           <p:nvPr/>
         </p:nvSpPr>
@@ -8473,14 +8473,14 @@
       </p:sp>
       <p:sp>
         <p:nvSpPr>
-          <p:cNvPr id="16" name="TextBox 15"/>
+          <p:cNvPr id="17" name="TextBox 16"/>
           <p:cNvSpPr txBox="1"/>
           <p:nvPr/>
         </p:nvSpPr>
         <p:spPr>
           <a:xfrm>
-            <a:off x="2935223" y="4434840"/>
-            <a:ext cx="1920239" cy="1645920"/>
+            <a:off x="2916935" y="4407408"/>
+            <a:ext cx="1956815" cy="256032"/>
           </a:xfrm>
           <a:prstGeom prst="rect">
             <a:avLst/>
@@ -8488,58 +8488,58 @@
           <a:noFill/>
         </p:spPr>
         <p:txBody>
-          <a:bodyPr wrap="square">
+          <a:bodyPr wrap="none">
             <a:spAutoFit/>
           </a:bodyPr>
           <a:lstStyle/>
           <a:p>
             <a:pPr>
-              <a:defRPr b="1" sz="900">
+              <a:defRPr b="1" sz="850">
                 <a:solidFill>
                   <a:srgbClr val="123A8A"/>
                 </a:solidFill>
               </a:defRPr>
             </a:pPr>
             <a:r>
-              <a:t>[2] DYNAMIC DISTRESS (DDS)</a:t>
-            </a:r>
-          </a:p>
-          <a:p>
-            <a:pPr>
-              <a:defRPr b="1" sz="850">
-                <a:solidFill>
-                  <a:srgbClr val="0F172A"/>
-                </a:solidFill>
-              </a:defRPr>
-            </a:pPr>
-            <a:r>
-              <a:t>Multi-Signal Metric (0-100)</a:t>
-            </a:r>
-          </a:p>
-          <a:p>
-            <a:pPr>
-              <a:defRPr sz="800">
-                <a:solidFill>
-                  <a:srgbClr val="64748B"/>
-                </a:solidFill>
-              </a:defRPr>
-            </a:pPr>
-            <a:r>
-              <a:t>Acoustic tremor + BERT emotion + FIR severity + legal delay.</a:t>
-            </a:r>
-          </a:p>
-        </p:txBody>
-      </p:sp>
-      <p:sp>
-        <p:nvSpPr>
-          <p:cNvPr id="17" name="Rounded Rectangle 16"/>
+              <a:t>Outcome 2: Emotion Wheel</a:t>
+            </a:r>
+          </a:p>
+        </p:txBody>
+      </p:sp>
+      <p:pic>
+        <p:nvPicPr>
+          <p:cNvPr id="18" name="Picture 17" descr="photo_outcome2_emotion.png"/>
+          <p:cNvPicPr>
+            <a:picLocks noChangeAspect="1"/>
+          </p:cNvPicPr>
+          <p:nvPr/>
+        </p:nvPicPr>
+        <p:blipFill>
+          <a:blip r:embed="rId4"/>
+          <a:stretch>
+            <a:fillRect/>
+          </a:stretch>
+        </p:blipFill>
+        <p:spPr>
+          <a:xfrm>
+            <a:off x="2916935" y="4681728"/>
+            <a:ext cx="1956815" cy="1444752"/>
+          </a:xfrm>
+          <a:prstGeom prst="rect">
+            <a:avLst/>
+          </a:prstGeom>
+        </p:spPr>
+      </p:pic>
+      <p:sp>
+        <p:nvSpPr>
+          <p:cNvPr id="19" name="Rounded Rectangle 18"/>
           <p:cNvSpPr/>
           <p:nvPr/>
         </p:nvSpPr>
         <p:spPr>
           <a:xfrm>
             <a:off x="5038342" y="4343400"/>
-            <a:ext cx="2066543" cy="1828800"/>
+            <a:ext cx="2066543" cy="1874519"/>
           </a:xfrm>
           <a:prstGeom prst="roundRect">
             <a:avLst/>
@@ -8577,7 +8577,7 @@
       </p:sp>
       <p:sp>
         <p:nvSpPr>
-          <p:cNvPr id="18" name="Rectangle 17"/>
+          <p:cNvPr id="20" name="Rectangle 19"/>
           <p:cNvSpPr/>
           <p:nvPr/>
         </p:nvSpPr>
@@ -8620,14 +8620,14 @@
       </p:sp>
       <p:sp>
         <p:nvSpPr>
-          <p:cNvPr id="19" name="TextBox 18"/>
+          <p:cNvPr id="21" name="TextBox 20"/>
           <p:cNvSpPr txBox="1"/>
           <p:nvPr/>
         </p:nvSpPr>
         <p:spPr>
           <a:xfrm>
-            <a:off x="5111494" y="4434840"/>
-            <a:ext cx="1920239" cy="1645920"/>
+            <a:off x="5093206" y="4407408"/>
+            <a:ext cx="1956815" cy="256032"/>
           </a:xfrm>
           <a:prstGeom prst="rect">
             <a:avLst/>
@@ -8635,58 +8635,58 @@
           <a:noFill/>
         </p:spPr>
         <p:txBody>
-          <a:bodyPr wrap="square">
+          <a:bodyPr wrap="none">
             <a:spAutoFit/>
           </a:bodyPr>
           <a:lstStyle/>
           <a:p>
             <a:pPr>
-              <a:defRPr b="1" sz="900">
+              <a:defRPr b="1" sz="850">
                 <a:solidFill>
                   <a:srgbClr val="123A8A"/>
                 </a:solidFill>
               </a:defRPr>
             </a:pPr>
             <a:r>
-              <a:t>[3] 72H CRISIS FORECASTER</a:t>
-            </a:r>
-          </a:p>
-          <a:p>
-            <a:pPr>
-              <a:defRPr b="1" sz="850">
-                <a:solidFill>
-                  <a:srgbClr val="0F172A"/>
-                </a:solidFill>
-              </a:defRPr>
-            </a:pPr>
-            <a:r>
-              <a:t>Velocity Prediction (dDDS/dt)</a:t>
-            </a:r>
-          </a:p>
-          <a:p>
-            <a:pPr>
-              <a:defRPr sz="800">
-                <a:solidFill>
-                  <a:srgbClr val="64748B"/>
-                </a:solidFill>
-              </a:defRPr>
-            </a:pPr>
-            <a:r>
-              <a:t>Time-series trend forecasting acute trauma 72h prior to crisis.</a:t>
-            </a:r>
-          </a:p>
-        </p:txBody>
-      </p:sp>
-      <p:sp>
-        <p:nvSpPr>
-          <p:cNvPr id="20" name="Rounded Rectangle 19"/>
+              <a:t>Outcome 3: Calm Sanctuary</a:t>
+            </a:r>
+          </a:p>
+        </p:txBody>
+      </p:sp>
+      <p:pic>
+        <p:nvPicPr>
+          <p:cNvPr id="22" name="Picture 21" descr="photo_outcome3_calm.png"/>
+          <p:cNvPicPr>
+            <a:picLocks noChangeAspect="1"/>
+          </p:cNvPicPr>
+          <p:nvPr/>
+        </p:nvPicPr>
+        <p:blipFill>
+          <a:blip r:embed="rId5"/>
+          <a:stretch>
+            <a:fillRect/>
+          </a:stretch>
+        </p:blipFill>
+        <p:spPr>
+          <a:xfrm>
+            <a:off x="5093206" y="4681728"/>
+            <a:ext cx="1956815" cy="1444752"/>
+          </a:xfrm>
+          <a:prstGeom prst="rect">
+            <a:avLst/>
+          </a:prstGeom>
+        </p:spPr>
+      </p:pic>
+      <p:sp>
+        <p:nvSpPr>
+          <p:cNvPr id="23" name="Rounded Rectangle 22"/>
           <p:cNvSpPr/>
           <p:nvPr/>
         </p:nvSpPr>
         <p:spPr>
           <a:xfrm>
             <a:off x="7214613" y="4343400"/>
-            <a:ext cx="2066543" cy="1828800"/>
+            <a:ext cx="2066543" cy="1874519"/>
           </a:xfrm>
           <a:prstGeom prst="roundRect">
             <a:avLst/>
@@ -8724,7 +8724,7 @@
       </p:sp>
       <p:sp>
         <p:nvSpPr>
-          <p:cNvPr id="21" name="Rectangle 20"/>
+          <p:cNvPr id="24" name="Rectangle 23"/>
           <p:cNvSpPr/>
           <p:nvPr/>
         </p:nvSpPr>
@@ -8767,14 +8767,14 @@
       </p:sp>
       <p:sp>
         <p:nvSpPr>
-          <p:cNvPr id="22" name="TextBox 21"/>
+          <p:cNvPr id="25" name="TextBox 24"/>
           <p:cNvSpPr txBox="1"/>
           <p:nvPr/>
         </p:nvSpPr>
         <p:spPr>
           <a:xfrm>
-            <a:off x="7287765" y="4434840"/>
-            <a:ext cx="1920239" cy="1645920"/>
+            <a:off x="7269477" y="4407408"/>
+            <a:ext cx="1956815" cy="256032"/>
           </a:xfrm>
           <a:prstGeom prst="rect">
             <a:avLst/>
@@ -8782,58 +8782,58 @@
           <a:noFill/>
         </p:spPr>
         <p:txBody>
-          <a:bodyPr wrap="square">
+          <a:bodyPr wrap="none">
             <a:spAutoFit/>
           </a:bodyPr>
           <a:lstStyle/>
           <a:p>
             <a:pPr>
-              <a:defRPr b="1" sz="900">
+              <a:defRPr b="1" sz="850">
                 <a:solidFill>
                   <a:srgbClr val="123A8A"/>
                 </a:solidFill>
               </a:defRPr>
             </a:pPr>
             <a:r>
-              <a:t>[4] 3-TIER ACTION MATRIX</a:t>
-            </a:r>
-          </a:p>
-          <a:p>
-            <a:pPr>
-              <a:defRPr b="1" sz="850">
-                <a:solidFill>
-                  <a:srgbClr val="0F172A"/>
-                </a:solidFill>
-              </a:defRPr>
-            </a:pPr>
-            <a:r>
-              <a:t>DM / SP Incident Dispatch</a:t>
-            </a:r>
-          </a:p>
-          <a:p>
-            <a:pPr>
-              <a:defRPr sz="800">
-                <a:solidFill>
-                  <a:srgbClr val="64748B"/>
-                </a:solidFill>
-              </a:defRPr>
-            </a:pPr>
-            <a:r>
-              <a:t>Automated alert dispatch to district magistrate, police &amp; counsellors.</a:t>
-            </a:r>
-          </a:p>
-        </p:txBody>
-      </p:sp>
-      <p:sp>
-        <p:nvSpPr>
-          <p:cNvPr id="23" name="Rounded Rectangle 22"/>
+              <a:t>Outcome 4: 7-Day DDS Trend</a:t>
+            </a:r>
+          </a:p>
+        </p:txBody>
+      </p:sp>
+      <p:pic>
+        <p:nvPicPr>
+          <p:cNvPr id="26" name="Picture 25" descr="photo_outcome4_progress.png"/>
+          <p:cNvPicPr>
+            <a:picLocks noChangeAspect="1"/>
+          </p:cNvPicPr>
+          <p:nvPr/>
+        </p:nvPicPr>
+        <p:blipFill>
+          <a:blip r:embed="rId6"/>
+          <a:stretch>
+            <a:fillRect/>
+          </a:stretch>
+        </p:blipFill>
+        <p:spPr>
+          <a:xfrm>
+            <a:off x="7269477" y="4681728"/>
+            <a:ext cx="1956815" cy="1444752"/>
+          </a:xfrm>
+          <a:prstGeom prst="rect">
+            <a:avLst/>
+          </a:prstGeom>
+        </p:spPr>
+      </p:pic>
+      <p:sp>
+        <p:nvSpPr>
+          <p:cNvPr id="27" name="Rounded Rectangle 26"/>
           <p:cNvSpPr/>
           <p:nvPr/>
         </p:nvSpPr>
         <p:spPr>
           <a:xfrm>
             <a:off x="9390884" y="4343400"/>
-            <a:ext cx="2066543" cy="1828800"/>
+            <a:ext cx="2066543" cy="1874519"/>
           </a:xfrm>
           <a:prstGeom prst="roundRect">
             <a:avLst/>
@@ -8871,7 +8871,7 @@
       </p:sp>
       <p:sp>
         <p:nvSpPr>
-          <p:cNvPr id="24" name="Rectangle 23"/>
+          <p:cNvPr id="28" name="Rectangle 27"/>
           <p:cNvSpPr/>
           <p:nvPr/>
         </p:nvSpPr>
@@ -8914,14 +8914,14 @@
       </p:sp>
       <p:sp>
         <p:nvSpPr>
-          <p:cNvPr id="25" name="TextBox 24"/>
+          <p:cNvPr id="29" name="TextBox 28"/>
           <p:cNvSpPr txBox="1"/>
           <p:nvPr/>
         </p:nvSpPr>
         <p:spPr>
           <a:xfrm>
-            <a:off x="9464036" y="4434840"/>
-            <a:ext cx="1920239" cy="1645920"/>
+            <a:off x="9445748" y="4407408"/>
+            <a:ext cx="1956815" cy="256032"/>
           </a:xfrm>
           <a:prstGeom prst="rect">
             <a:avLst/>
@@ -8929,48 +8929,48 @@
           <a:noFill/>
         </p:spPr>
         <p:txBody>
-          <a:bodyPr wrap="square">
+          <a:bodyPr wrap="none">
             <a:spAutoFit/>
           </a:bodyPr>
           <a:lstStyle/>
           <a:p>
             <a:pPr>
-              <a:defRPr b="1" sz="900">
+              <a:defRPr b="1" sz="850">
                 <a:solidFill>
                   <a:srgbClr val="123A8A"/>
                 </a:solidFill>
               </a:defRPr>
             </a:pPr>
             <a:r>
-              <a:t>[5] RULE 12(4) RELIEF VAULT</a:t>
-            </a:r>
-          </a:p>
-          <a:p>
-            <a:pPr>
-              <a:defRPr b="1" sz="850">
-                <a:solidFill>
-                  <a:srgbClr val="0F172A"/>
-                </a:solidFill>
-              </a:defRPr>
-            </a:pPr>
-            <a:r>
-              <a:t>Relief &amp; Tamper Ledger</a:t>
-            </a:r>
-          </a:p>
-          <a:p>
-            <a:pPr>
-              <a:defRPr sz="800">
-                <a:solidFill>
-                  <a:srgbClr val="64748B"/>
-                </a:solidFill>
-              </a:defRPr>
-            </a:pPr>
-            <a:r>
-              <a:t>Automated milestone relief tracking with SHA-256 audit logs.</a:t>
-            </a:r>
-          </a:p>
-        </p:txBody>
-      </p:sp>
+              <a:t>Outcome 5: Officer HUD</a:t>
+            </a:r>
+          </a:p>
+        </p:txBody>
+      </p:sp>
+      <p:pic>
+        <p:nvPicPr>
+          <p:cNvPr id="30" name="Picture 29" descr="photo_outcome5_officer.png"/>
+          <p:cNvPicPr>
+            <a:picLocks noChangeAspect="1"/>
+          </p:cNvPicPr>
+          <p:nvPr/>
+        </p:nvPicPr>
+        <p:blipFill>
+          <a:blip r:embed="rId7"/>
+          <a:stretch>
+            <a:fillRect/>
+          </a:stretch>
+        </p:blipFill>
+        <p:spPr>
+          <a:xfrm>
+            <a:off x="9445748" y="4681728"/>
+            <a:ext cx="1956815" cy="1444752"/>
+          </a:xfrm>
+          <a:prstGeom prst="rect">
+            <a:avLst/>
+          </a:prstGeom>
+        </p:spPr>
+      </p:pic>
     </p:spTree>
   </p:cSld>
   <p:clrMapOvr>

</xml_diff>

<commit_message>
feat: incorporate 3-tier dashboard hierarchy and multi-domain intervention logic into slides and submission text
</commit_message>
<xml_diff>
--- a/SIH2026_DEKO_SIH26094_Presentation.pptx
+++ b/SIH2026_DEKO_SIH26094_Presentation.pptx
@@ -4144,16 +4144,16 @@
           <a:p>
             <a:pPr>
               <a:spcAft>
-                <a:spcPts val="600"/>
+                <a:spcPts val="400"/>
               </a:spcAft>
-              <a:defRPr b="1" sz="1200">
+              <a:defRPr b="1" sz="1100">
                 <a:solidFill>
                   <a:srgbClr val="123A8A"/>
                 </a:solidFill>
               </a:defRPr>
             </a:pPr>
             <a:r>
-              <a:t>District Magistrate, Police &amp; Tele-Counsellor Command (Triage &amp; Case Action)</a:t>
+              <a:t>3-Tier Command HUD: District (DM/SP) -&gt; State Nodal -&gt; National (MoSJE)</a:t>
             </a:r>
           </a:p>
           <a:p>
@@ -4168,7 +4168,7 @@
                   <a:srgbClr val="0F172A"/>
                 </a:solidFill>
               </a:rPr>
-              <a:t>• Unified Real-Time Distress HUD: </a:t>
+              <a:t>• District Level (DM, SP, DLSA): </a:t>
             </a:r>
             <a:r>
               <a:rPr sz="950">
@@ -4176,7 +4176,7 @@
                   <a:srgbClr val="334155"/>
                 </a:solidFill>
               </a:rPr>
-              <a:t>District map visualizes victim distress velocity, hotspot clusters &amp; overdue relief.</a:t>
+              <a:t>Case-level telemetry, XAI factor cards, local crisis team &amp; Sec 15A protection.</a:t>
             </a:r>
           </a:p>
           <a:p>
@@ -4191,7 +4191,7 @@
                   <a:srgbClr val="0F172A"/>
                 </a:solidFill>
               </a:rPr>
-              <a:t>• Automated Red-Band Alerts: </a:t>
+              <a:t>• State Level (State Nodal Officer): </a:t>
             </a:r>
             <a:r>
               <a:rPr sz="950">
@@ -4199,7 +4199,7 @@
                   <a:srgbClr val="334155"/>
                 </a:solidFill>
               </a:rPr>
-              <a:t>Real-time emergency escalation to DM, SP &amp; designated counsellors when score &gt; 60.</a:t>
+              <a:t>Inter-district resource allocation, statewide distress heatmap &amp; Rule 12(4) tracking.</a:t>
             </a:r>
           </a:p>
           <a:p>
@@ -4214,7 +4214,7 @@
                   <a:srgbClr val="0F172A"/>
                 </a:solidFill>
               </a:rPr>
-              <a:t>• Statutory Relief Tracking: </a:t>
+              <a:t>• National Level (MoSJE Central): </a:t>
             </a:r>
             <a:r>
               <a:rPr sz="950">
@@ -4222,7 +4222,7 @@
                   <a:srgbClr val="334155"/>
                 </a:solidFill>
               </a:rPr>
-              <a:t>Tracks Section 15A witness protection protocols and Rule 12(4) stage-wise relief disbursement.</a:t>
+              <a:t>Centrally sponsored scheme oversight, national vulnerability trends &amp; policy analytics.</a:t>
             </a:r>
           </a:p>
         </p:txBody>
@@ -6045,7 +6045,7 @@
               </a:defRPr>
             </a:pPr>
             <a:r>
-              <a:t>DDS = 0.25E + 0.20V + 0.15B + 0.15H + 0.10C + 0.15T multi-signal.</a:t>
+              <a:t>DDS = 0.25E + 0.20V + 0.15B + 0.15H + 0.10C + 0.15T multi-signal metric.</a:t>
             </a:r>
           </a:p>
         </p:txBody>
@@ -6125,7 +6125,7 @@
               </a:defRPr>
             </a:pPr>
             <a:r>
-              <a:t>Multi-Agency Integration Layer</a:t>
+              <a:t>AI Statutory Recommendation Engine</a:t>
             </a:r>
           </a:p>
           <a:p>
@@ -6137,7 +6137,7 @@
               </a:defRPr>
             </a:pPr>
             <a:r>
-              <a:t>112/medical/protection/legal integrations demonstrated through prototype adapters.</a:t>
+              <a:t>NLP triggers 4 specific actions: Medical care, Sec 15A Relocation, DLSA Legal aid &amp; Rule 12(4) DBT.</a:t>
             </a:r>
           </a:p>
         </p:txBody>
@@ -7659,7 +7659,7 @@
                   <a:srgbClr val="0F172A"/>
                 </a:solidFill>
               </a:rPr>
-              <a:t>Rule 12(4) Relief &amp; Rehab Tracking: </a:t>
+              <a:t>Targeted Statutory Redress: </a:t>
             </a:r>
             <a:r>
               <a:rPr sz="950">
@@ -7667,7 +7667,7 @@
                   <a:srgbClr val="334155"/>
                 </a:solidFill>
               </a:rPr>
-              <a:t>Supports stage-wise relief, sanction and 7-day monitoring + welfare coordination.</a:t>
+              <a:t>AI NLP precisely recommends Medical care, Sec 15A Relocation, DLSA Legal aid &amp; Rule 12(4) DBT relief.</a:t>
             </a:r>
           </a:p>
           <a:p>
@@ -8359,33 +8359,9 @@
           </a:p>
         </p:txBody>
       </p:sp>
-      <p:pic>
-        <p:nvPicPr>
-          <p:cNvPr id="14" name="Picture 13" descr="photo_outcome1_chat.png"/>
-          <p:cNvPicPr>
-            <a:picLocks noChangeAspect="1"/>
-          </p:cNvPicPr>
-          <p:nvPr/>
-        </p:nvPicPr>
-        <p:blipFill>
-          <a:blip r:embed="rId3"/>
-          <a:stretch>
-            <a:fillRect/>
-          </a:stretch>
-        </p:blipFill>
-        <p:spPr>
-          <a:xfrm>
-            <a:off x="740664" y="4681728"/>
-            <a:ext cx="1956815" cy="1444752"/>
-          </a:xfrm>
-          <a:prstGeom prst="rect">
-            <a:avLst/>
-          </a:prstGeom>
-        </p:spPr>
-      </p:pic>
-      <p:sp>
-        <p:nvSpPr>
-          <p:cNvPr id="15" name="Rounded Rectangle 14"/>
+      <p:sp>
+        <p:nvSpPr>
+          <p:cNvPr id="14" name="Rounded Rectangle 13"/>
           <p:cNvSpPr/>
           <p:nvPr/>
         </p:nvSpPr>
@@ -8430,7 +8406,7 @@
       </p:sp>
       <p:sp>
         <p:nvSpPr>
-          <p:cNvPr id="16" name="Rectangle 15"/>
+          <p:cNvPr id="15" name="Rectangle 14"/>
           <p:cNvSpPr/>
           <p:nvPr/>
         </p:nvSpPr>
@@ -8473,7 +8449,7 @@
       </p:sp>
       <p:sp>
         <p:nvSpPr>
-          <p:cNvPr id="17" name="TextBox 16"/>
+          <p:cNvPr id="16" name="TextBox 15"/>
           <p:cNvSpPr txBox="1"/>
           <p:nvPr/>
         </p:nvSpPr>
@@ -8506,33 +8482,9 @@
           </a:p>
         </p:txBody>
       </p:sp>
-      <p:pic>
-        <p:nvPicPr>
-          <p:cNvPr id="18" name="Picture 17" descr="photo_outcome2_emotion.png"/>
-          <p:cNvPicPr>
-            <a:picLocks noChangeAspect="1"/>
-          </p:cNvPicPr>
-          <p:nvPr/>
-        </p:nvPicPr>
-        <p:blipFill>
-          <a:blip r:embed="rId4"/>
-          <a:stretch>
-            <a:fillRect/>
-          </a:stretch>
-        </p:blipFill>
-        <p:spPr>
-          <a:xfrm>
-            <a:off x="2916935" y="4681728"/>
-            <a:ext cx="1956815" cy="1444752"/>
-          </a:xfrm>
-          <a:prstGeom prst="rect">
-            <a:avLst/>
-          </a:prstGeom>
-        </p:spPr>
-      </p:pic>
-      <p:sp>
-        <p:nvSpPr>
-          <p:cNvPr id="19" name="Rounded Rectangle 18"/>
+      <p:sp>
+        <p:nvSpPr>
+          <p:cNvPr id="17" name="Rounded Rectangle 16"/>
           <p:cNvSpPr/>
           <p:nvPr/>
         </p:nvSpPr>
@@ -8577,7 +8529,7 @@
       </p:sp>
       <p:sp>
         <p:nvSpPr>
-          <p:cNvPr id="20" name="Rectangle 19"/>
+          <p:cNvPr id="18" name="Rectangle 17"/>
           <p:cNvSpPr/>
           <p:nvPr/>
         </p:nvSpPr>
@@ -8620,7 +8572,7 @@
       </p:sp>
       <p:sp>
         <p:nvSpPr>
-          <p:cNvPr id="21" name="TextBox 20"/>
+          <p:cNvPr id="19" name="TextBox 18"/>
           <p:cNvSpPr txBox="1"/>
           <p:nvPr/>
         </p:nvSpPr>
@@ -8653,33 +8605,9 @@
           </a:p>
         </p:txBody>
       </p:sp>
-      <p:pic>
-        <p:nvPicPr>
-          <p:cNvPr id="22" name="Picture 21" descr="photo_outcome3_calm.png"/>
-          <p:cNvPicPr>
-            <a:picLocks noChangeAspect="1"/>
-          </p:cNvPicPr>
-          <p:nvPr/>
-        </p:nvPicPr>
-        <p:blipFill>
-          <a:blip r:embed="rId5"/>
-          <a:stretch>
-            <a:fillRect/>
-          </a:stretch>
-        </p:blipFill>
-        <p:spPr>
-          <a:xfrm>
-            <a:off x="5093206" y="4681728"/>
-            <a:ext cx="1956815" cy="1444752"/>
-          </a:xfrm>
-          <a:prstGeom prst="rect">
-            <a:avLst/>
-          </a:prstGeom>
-        </p:spPr>
-      </p:pic>
-      <p:sp>
-        <p:nvSpPr>
-          <p:cNvPr id="23" name="Rounded Rectangle 22"/>
+      <p:sp>
+        <p:nvSpPr>
+          <p:cNvPr id="20" name="Rounded Rectangle 19"/>
           <p:cNvSpPr/>
           <p:nvPr/>
         </p:nvSpPr>
@@ -8724,7 +8652,7 @@
       </p:sp>
       <p:sp>
         <p:nvSpPr>
-          <p:cNvPr id="24" name="Rectangle 23"/>
+          <p:cNvPr id="21" name="Rectangle 20"/>
           <p:cNvSpPr/>
           <p:nvPr/>
         </p:nvSpPr>
@@ -8767,7 +8695,7 @@
       </p:sp>
       <p:sp>
         <p:nvSpPr>
-          <p:cNvPr id="25" name="TextBox 24"/>
+          <p:cNvPr id="22" name="TextBox 21"/>
           <p:cNvSpPr txBox="1"/>
           <p:nvPr/>
         </p:nvSpPr>
@@ -8800,33 +8728,9 @@
           </a:p>
         </p:txBody>
       </p:sp>
-      <p:pic>
-        <p:nvPicPr>
-          <p:cNvPr id="26" name="Picture 25" descr="photo_outcome4_progress.png"/>
-          <p:cNvPicPr>
-            <a:picLocks noChangeAspect="1"/>
-          </p:cNvPicPr>
-          <p:nvPr/>
-        </p:nvPicPr>
-        <p:blipFill>
-          <a:blip r:embed="rId6"/>
-          <a:stretch>
-            <a:fillRect/>
-          </a:stretch>
-        </p:blipFill>
-        <p:spPr>
-          <a:xfrm>
-            <a:off x="7269477" y="4681728"/>
-            <a:ext cx="1956815" cy="1444752"/>
-          </a:xfrm>
-          <a:prstGeom prst="rect">
-            <a:avLst/>
-          </a:prstGeom>
-        </p:spPr>
-      </p:pic>
-      <p:sp>
-        <p:nvSpPr>
-          <p:cNvPr id="27" name="Rounded Rectangle 26"/>
+      <p:sp>
+        <p:nvSpPr>
+          <p:cNvPr id="23" name="Rounded Rectangle 22"/>
           <p:cNvSpPr/>
           <p:nvPr/>
         </p:nvSpPr>
@@ -8871,7 +8775,7 @@
       </p:sp>
       <p:sp>
         <p:nvSpPr>
-          <p:cNvPr id="28" name="Rectangle 27"/>
+          <p:cNvPr id="24" name="Rectangle 23"/>
           <p:cNvSpPr/>
           <p:nvPr/>
         </p:nvSpPr>
@@ -8914,7 +8818,7 @@
       </p:sp>
       <p:sp>
         <p:nvSpPr>
-          <p:cNvPr id="29" name="TextBox 28"/>
+          <p:cNvPr id="25" name="TextBox 24"/>
           <p:cNvSpPr txBox="1"/>
           <p:nvPr/>
         </p:nvSpPr>
@@ -8947,30 +8851,6 @@
           </a:p>
         </p:txBody>
       </p:sp>
-      <p:pic>
-        <p:nvPicPr>
-          <p:cNvPr id="30" name="Picture 29" descr="photo_outcome5_officer.png"/>
-          <p:cNvPicPr>
-            <a:picLocks noChangeAspect="1"/>
-          </p:cNvPicPr>
-          <p:nvPr/>
-        </p:nvPicPr>
-        <p:blipFill>
-          <a:blip r:embed="rId7"/>
-          <a:stretch>
-            <a:fillRect/>
-          </a:stretch>
-        </p:blipFill>
-        <p:spPr>
-          <a:xfrm>
-            <a:off x="9445748" y="4681728"/>
-            <a:ext cx="1956815" cy="1444752"/>
-          </a:xfrm>
-          <a:prstGeom prst="rect">
-            <a:avLst/>
-          </a:prstGeom>
-        </p:spPr>
-      </p:pic>
     </p:spTree>
   </p:cSld>
   <p:clrMapOvr>

</xml_diff>